<commit_message>
fix: compatibilidad con scikit-learn 1.9, reejecución local y métricas actualizadas (ROC-AUC 0.776)
</commit_message>
<xml_diff>
--- a/Presentacion.pptx
+++ b/Presentacion.pptx
@@ -1570,7 +1570,7 @@
           <a:p>
             <a:r>
               <a:rPr lang="en-US" dirty="0"/>
-              <a:t>En test: ROC-AUC 0.775 y F1 0.869. El test se reserva hasta el final.</a:t>
+              <a:t>En test: ROC-AUC 0.776 y F1 0.869. El test se reserva hasta el final.</a:t>
             </a:r>
             <a:endParaRPr lang="en-US" dirty="0"/>
           </a:p>
@@ -2113,7 +2113,7 @@
                 <a:ea typeface="Calibri" pitchFamily="34" charset="-122"/>
                 <a:cs typeface="Calibri" pitchFamily="34" charset="-120"/>
               </a:rPr>
-              <a:t>122.611 juegos analizados  ·  clasificación binaria  ·  ROC-AUC 0.775 en test</a:t>
+              <a:t>122.611 juegos analizados  ·  clasificación binaria  ·  ROC-AUC 0.776 en test</a:t>
             </a:r>
             <a:endParaRPr lang="en-US" sz="1300" dirty="0"/>
           </a:p>
@@ -3107,7 +3107,7 @@
                 <a:ea typeface="Calibri" pitchFamily="34" charset="-122"/>
                 <a:cs typeface="Calibri" pitchFamily="34" charset="-120"/>
               </a:rPr>
-              <a:t>ROC-AUC 0.775 frente a 0.50 del baseline</a:t>
+              <a:t>ROC-AUC 0.776 frente a 0.50 del baseline</a:t>
             </a:r>
             <a:endParaRPr lang="en-US" sz="1350" dirty="0"/>
           </a:p>
@@ -6998,7 +6998,7 @@
                 <a:ea typeface="Cambria" pitchFamily="34" charset="-122"/>
                 <a:cs typeface="Cambria" pitchFamily="34" charset="-120"/>
               </a:rPr>
-              <a:t>0.775</a:t>
+              <a:t>0.776</a:t>
             </a:r>
             <a:endParaRPr lang="en-US" sz="4600" dirty="0"/>
           </a:p>

</xml_diff>